<commit_message>
Q5: reconcile the script and deck with the current notebook figures
The branch had moved on 40 commits; these are the numbers as the executed
notebook now reports them. ASC-204's cluster is 266 trials / 246 same area /
34 negative readouts; ordering separates by 16-27 points; within-positive R2
is 0.03; the worst decile is 61% beyond -10%; the leakage audit runs 0.20 to
0.96 with the risk index worth +0.140; forward chaining gives 0.172; the
negative bands are 69 points. The price-history point now says what Q3b says:
the dataset supplies no series for ASCL, which is a gap in the data rather
than a fact about a company that is listed.

Co-Authored-By: Claude Opus 5 <noreply@anthropic.com>
Claude-Session: https://claude.ai/code/session_01Wi5E7jHu2EBxSFfDGUiyKF
</commit_message>
<xml_diff>
--- a/q5_video/Q5_handover_deck.pptx
+++ b/q5_video/Q5_handover_deck.pptx
@@ -514,7 +514,7 @@
           <a:p/>
           <a:p>
             <a:r>
-              <a:t>Hello. I'm handing over the analysis behind the IR team's estimates of how the market will react to our three upcoming readouts. My position: it's fit to inform those estimates, but not to produce a headline number, and it's far stronger on the downside than the upside. I'll cover what it supports, where it shouldn't be relied on, how it was produced, and how I checked it.</a:t>
+              <a:t>Hello. I'm handing over the analysis behind the IR team's estimates of how the market will react to our three upcoming readouts. My position: it's fit to inform those estimates, but not to produce a headline number, and it's far stronger on the downside than the upside. I'll cover what it supports, where it shouldn't be, how it was produced, and how I checked it.</a:t>
             </a:r>
           </a:p>
         </p:txBody>
@@ -666,19 +666,19 @@
           <a:p/>
           <a:p>
             <a:r>
-              <a:t>First, the ordering. For all three assets a negative readout is materially worse than a positive one, by fifteen to twenty-five points of central estimate, and that survives every seed I ran.</a:t>
+              <a:t>First, the ordering. For all three assets a negative readout is materially worse than a positive one, by sixteen to twenty-seven points of central estimate, and that survives every seed I ran.</a:t>
             </a:r>
           </a:p>
           <a:p/>
           <a:p>
             <a:r>
-              <a:t>Second, the downside for ASC-204. It sits in a cluster of 274 cardiovascular and renal outcome trials, 247 in the same therapeutic area, with 39 negative readouts behind the distribution. That's the estimate I'd let the funding decision rest on.</a:t>
+              <a:t>Second, the downside for ASC-204. It sits in a cluster of 266 cardiovascular and renal outcome trials, 246 in the same therapeutic area, with 34 negative readouts behind the distribution. That's the estimate I'd let the funding decision rest on.</a:t>
             </a:r>
           </a:p>
           <a:p/>
           <a:p>
             <a:r>
-              <a:t>[CUT IF LONG] Third, ranking severity. Of the announcements the model puts in its worst decile, 60 per cent fell more than ten per cent and 43 per cent fell more than twenty-five. It sorts readouts into 'could be severe' and 'probably won't be'. It won't tell you a stock moves fourteen per cent.</a:t>
+              <a:t>[CUT IF LONG] Third, ranking severity. Of the announcements the model puts in its worst decile, 61 per cent fell more than ten per cent and 43 per cent fell more than twenty-five. It sorts readouts into 'could be severe' and 'probably won't be' — not into a number.</a:t>
             </a:r>
           </a:p>
         </p:txBody>
@@ -766,13 +766,13 @@
           <a:p/>
           <a:p>
             <a:r>
-              <a:t>The upside is close to unmodelled. Within positive readouts the model explains about five per cent of the spread, and effectively nothing once I'm limited to what Asclepius can supply. For an upside case, quote the historical range, not a model output.</a:t>
+              <a:t>The upside is close to unmodelled. Within positive readouts the model explains about three per cent of the spread, and effectively nothing once I'm limited to what Asclepius can supply. For an upside case, quote the historical range, not a model output.</a:t>
             </a:r>
           </a:p>
           <a:p/>
           <a:p>
             <a:r>
-              <a:t>And Asclepius has no price history in this database. Volatility is most of what let the model size a bad outcome, so the bands are wide — about 68 points. That width is correct, not a gap more modelling closes.</a:t>
+              <a:t>And the dataset supplies no price series for Asclepius — a gap in the data, not a fact about the company. Volatility is most of what let the model size a bad outcome, so the bands are about 69 points wide. That width is correct, not something more modelling closes.</a:t>
             </a:r>
           </a:p>
         </p:txBody>
@@ -948,19 +948,19 @@
           <a:p/>
           <a:p>
             <a:r>
-              <a:t>I ran a leakage audit before fitting anything. With the nine excluded columns put back, R-squared goes from 0.21 to 0.96. The one that mattered was my own data-quality index — it lifted R-squared by 0.086, until I traced it to one signal built from the realised return. That's the leakage that survives review: it looks legitimate, and the name gives nothing away.</a:t>
+              <a:t>I ran a leakage audit before fitting anything. With the nine excluded columns put back, R-squared goes from 0.20 to 0.96. The one that mattered was my own data-quality index — it lifted R-squared by 0.14, until I traced it to one signal built from the realised return. That's the leakage that survives review — the name gives nothing away.</a:t>
             </a:r>
           </a:p>
           <a:p/>
           <a:p>
             <a:r>
-              <a:t>[CUT IF LONG] I validated against honest nulls — permuted features for the clustering, bootstrap by filing rather than by row, and forward chaining, which drops R-squared from 0.20 to 0.16. That's what the pipeline can deliver.</a:t>
+              <a:t>[CUT IF LONG] I validated against honest nulls — permuted features for the clustering, bootstrap by filing rather than by row, and forward chaining, which drops R-squared from 0.20 to 0.17. That's what the pipeline can deliver.</a:t>
             </a:r>
           </a:p>
           <a:p/>
           <a:p>
             <a:r>
-              <a:t>And I corrected my own claims: I'd told the team the range width was mainly not knowing the result. It's about a quarter.</a:t>
+              <a:t>And I corrected my own claims: I'd told the team the range width was mainly the unknown result. It's about a quarter.</a:t>
             </a:r>
           </a:p>
         </p:txBody>
@@ -4636,7 +4636,7 @@
                 </a:solidFill>
                 <a:latin typeface="Calibri"/>
               </a:rPr>
-              <a:t>R² = 0.05 within positive readouts — use history, not the model</a:t>
+              <a:t>R² = 0.03 within positive readouts — use history, not the model</a:t>
             </a:r>
           </a:p>
           <a:p>
@@ -4994,7 +4994,7 @@
                 </a:solidFill>
                 <a:latin typeface="Calibri"/>
               </a:rPr>
-              <a:t>Negative vs positive separated by 15–25 points of central estimate, for all three assets, and it survives every seed.</a:t>
+              <a:t>Negative vs positive separated by 16–27 points of central estimate, for all three assets, and it survives every seed.</a:t>
             </a:r>
           </a:p>
           <a:p>
@@ -5038,7 +5038,7 @@
                 </a:solidFill>
                 <a:latin typeface="Calibri"/>
               </a:rPr>
-              <a:t>274-trial cardiovascular and renal cluster · 247 in the same therapeutic area · 39 negative readouts behind the distribution.</a:t>
+              <a:t>266-trial cardiovascular and renal cluster · 246 in the same therapeutic area · 34 negative readouts behind the distribution.</a:t>
             </a:r>
           </a:p>
           <a:p>
@@ -5082,7 +5082,7 @@
                 </a:solidFill>
                 <a:latin typeface="Calibri"/>
               </a:rPr>
-              <a:t>Worst-ranked decile: 60% fell more than 10%, 43% more than 25%. AUC 0.77 for a fall beyond 25%.</a:t>
+              <a:t>Worst-ranked decile: 61% fell more than 10%, 43% more than 25%. AUC 0.78 for a fall beyond 25%.</a:t>
             </a:r>
           </a:p>
         </p:txBody>
@@ -5440,7 +5440,7 @@
                 </a:solidFill>
                 <a:latin typeface="Calibri"/>
               </a:rPr>
-              <a:t>R² ≈ 0.05 within positives, ~0 with the features Asclepius can supply. Quote the comparable-set range instead.</a:t>
+              <a:t>R² ≈ 0.03 within positives, ~0 with the features Asclepius can supply. Quote the comparable-set range instead.</a:t>
             </a:r>
           </a:p>
           <a:p>
@@ -5462,7 +5462,7 @@
                 </a:solidFill>
                 <a:latin typeface="Calibri"/>
               </a:rPr>
-              <a:t>Asclepius has no price history here.</a:t>
+              <a:t>The dataset supplies no price series for ASCL.</a:t>
             </a:r>
           </a:p>
           <a:p>
@@ -5484,7 +5484,7 @@
                 </a:solidFill>
                 <a:latin typeface="Calibri"/>
               </a:rPr>
-              <a:t>Volatility did most of the work in sizing a bad outcome. Bands are ~68 points wide — correctly wide, not a gap more modelling closes.</a:t>
+              <a:t>A gap in the data, not a fact about the company. Volatility did most of the work in sizing a bad outcome, so bands are ~69 points wide — correctly wide.</a:t>
             </a:r>
           </a:p>
         </p:txBody>
@@ -6200,7 +6200,7 @@
                 </a:solidFill>
                 <a:latin typeface="Calibri"/>
               </a:rPr>
-              <a:t>R² 0.21 → 0.96 with the nine excluded columns put back.</a:t>
+              <a:t>R² 0.20 → 0.96 with the nine excluded columns put back.</a:t>
             </a:r>
           </a:p>
           <a:p>
@@ -6244,7 +6244,7 @@
                 </a:solidFill>
                 <a:latin typeface="Calibri"/>
               </a:rPr>
-              <a:t>+0.086 R², traced to one signal built from the realised return — the leakage that survives review, because the name gives nothing away.</a:t>
+              <a:t>+0.14 R², traced to one signal built from the realised return — the leakage that survives review, because the name gives nothing away.</a:t>
             </a:r>
           </a:p>
           <a:p>
@@ -6288,7 +6288,7 @@
                 </a:solidFill>
                 <a:latin typeface="Calibri"/>
               </a:rPr>
-              <a:t>Permuted features · bootstrap by filing, not by row · forward chaining takes R² from 0.20 to 0.16 — what the pipeline can deliver.</a:t>
+              <a:t>Permuted features · bootstrap by filing, not by row · forward chaining takes R² from 0.20 to 0.17 — what the pipeline can deliver.</a:t>
             </a:r>
           </a:p>
           <a:p>

</xml_diff>

<commit_message>
Q5: open with a summary of the work before handing over the results
The reviewing actuary has not seen any of this, so the video now spends ~43
seconds on the four stages before the opinion: the label validation and the
flagging screen over 4,539 classifications, the eight comparable families
over 1,975 readouts, the magnitude model, and the application to the three
readouts. Figures are the notebook's current ones (1,811 of 4,539 flagged =
40%, R2 0.20 headline).

The rest is tightened to absorb it - the roadmap sentence goes, and each
later section loses a clause - so the script runs 675 words, about 4:40
against the 5:00 limit, or 4:15 with the two passages marked cut-if-long
dropped. Deck gains a matching slide and its notes follow the new wording.

Co-Authored-By: Claude Opus 5 <noreply@anthropic.com>
Claude-Session: https://claude.ai/code/session_01Wi5E7jHu2EBxSFfDGUiyKF
</commit_message>
<xml_diff>
--- a/q5_video/Q5_handover_deck.pptx
+++ b/q5_video/Q5_handover_deck.pptx
@@ -12,6 +12,7 @@
     <p:sldId id="260" r:id="rId12"/>
     <p:sldId id="261" r:id="rId13"/>
     <p:sldId id="262" r:id="rId14"/>
+    <p:sldId id="263" r:id="rId15"/>
   </p:sldIdLst>
   <p:sldSz cx="12191695" cy="6858000" type="screen4x3"/>
   <p:notesSz cx="6858000" cy="9144000"/>
@@ -508,13 +509,13 @@
           <a:lstStyle/>
           <a:p>
             <a:r>
-              <a:t>[0:00 — ~28s]</a:t>
+              <a:t>[0:00 — ~19s]</a:t>
             </a:r>
           </a:p>
           <a:p/>
           <a:p>
             <a:r>
-              <a:t>Hello. I'm handing over the analysis behind the IR team's estimates of how the market will react to our three upcoming readouts. My position: it's fit to inform those estimates, but not to produce a headline number, and it's far stronger on the downside than the upside. I'll cover what it supports, where it shouldn't be, how it was produced, and how I checked it.</a:t>
+              <a:t>Hello. I'm handing over the analysis behind the IR team's estimates of how the market will react to our three upcoming readouts. My position: it's fit to inform those estimates, but not to produce a headline number, and it's far stronger on the downside than the upside.</a:t>
             </a:r>
           </a:p>
         </p:txBody>
@@ -584,7 +585,37 @@
           <a:lstStyle/>
           <a:p>
             <a:r>
-              <a:t>Hold this slide through the opening if you prefer a single frame while you set up the argument. Otherwise move here on 'far stronger on the downside than the upside'.</a:t>
+              <a:t>[0:19 — ~43s]</a:t>
+            </a:r>
+          </a:p>
+          <a:p/>
+          <a:p>
+            <a:r>
+              <a:t>Four stages.</a:t>
+            </a:r>
+          </a:p>
+          <a:p/>
+          <a:p>
+            <a:r>
+              <a:t>I validated the LLM's outcome labels — thirty filings read by hand against the original 8-Ks, then all 2,392 directional labels checked against the price move that followed. That gave a screen scoring all 4,539 classifications, which flags forty per cent, mostly for timing rather than a wrong label.</a:t>
+            </a:r>
+          </a:p>
+          <a:p/>
+          <a:p>
+            <a:r>
+              <a:t>I grouped 1,975 historical readouts into eight families, on disease, design, stage and sponsor, to find comparables.</a:t>
+            </a:r>
+          </a:p>
+          <a:p/>
+          <a:p>
+            <a:r>
+              <a:t>I modelled the three-day abnormal return from trial, text and company features; it explains twenty per cent of the variation.</a:t>
+            </a:r>
+          </a:p>
+          <a:p/>
+          <a:p>
+            <a:r>
+              <a:t>Then I applied that to our three readouts, three scenarios each, with a monitoring plan.</a:t>
             </a:r>
           </a:p>
         </p:txBody>
@@ -654,31 +685,7 @@
           <a:lstStyle/>
           <a:p>
             <a:r>
-              <a:t>[0:28 — ~53s]</a:t>
-            </a:r>
-          </a:p>
-          <a:p/>
-          <a:p>
-            <a:r>
-              <a:t>Three things I'd stand behind.</a:t>
-            </a:r>
-          </a:p>
-          <a:p/>
-          <a:p>
-            <a:r>
-              <a:t>First, the ordering. For all three assets a negative readout is materially worse than a positive one, by sixteen to twenty-seven points of central estimate, and that survives every seed I ran.</a:t>
-            </a:r>
-          </a:p>
-          <a:p/>
-          <a:p>
-            <a:r>
-              <a:t>Second, the downside for ASC-204. It sits in a cluster of 266 cardiovascular and renal outcome trials, 246 in the same therapeutic area, with 34 negative readouts behind the distribution. That's the estimate I'd let the funding decision rest on.</a:t>
-            </a:r>
-          </a:p>
-          <a:p/>
-          <a:p>
-            <a:r>
-              <a:t>[CUT IF LONG] Third, ranking severity. Of the announcements the model puts in its worst decile, 61 per cent fell more than ten per cent and 43 per cent fell more than twenty-five. It sorts readouts into 'could be severe' and 'probably won't be' — not into a number.</a:t>
+              <a:t>No script of its own — this frame carries the verdict while you move from what you built into the evidence for it. Land on it as you say 'so, three things I'd stand behind', then advance.</a:t>
             </a:r>
           </a:p>
         </p:txBody>
@@ -748,31 +755,31 @@
           <a:lstStyle/>
           <a:p>
             <a:r>
-              <a:t>[1:21 — ~57s]</a:t>
+              <a:t>[1:02 — ~45s]</a:t>
             </a:r>
           </a:p>
           <a:p/>
           <a:p>
             <a:r>
-              <a:t>Now the limits, and they're real.</a:t>
+              <a:t>So, three things I'd stand behind.</a:t>
             </a:r>
           </a:p>
           <a:p/>
           <a:p>
             <a:r>
-              <a:t>ASC-101 has effectively no comparables. The dataset holds seven hereditary angioedema readouts in total, so my method matched it on design, to vaccine trials, because it couldn't match on disease. That number is a Phase 3 base rate wearing a comparable set's clothes, and should be presented that way.</a:t>
+              <a:t>The ordering. For all three assets a negative readout is materially worse than a positive one, by sixteen to twenty-seven points of central estimate, and that survives every seed.</a:t>
             </a:r>
           </a:p>
           <a:p/>
           <a:p>
             <a:r>
-              <a:t>The upside is close to unmodelled. Within positive readouts the model explains about three per cent of the spread, and effectively nothing once I'm limited to what Asclepius can supply. For an upside case, quote the historical range, not a model output.</a:t>
+              <a:t>The downside for ASC-204. It sits in a cluster of 266 cardiovascular and renal outcome trials, 246 in the same therapeutic area, with 34 negative readouts behind it. That's the estimate I'd let the funding decision rest on.</a:t>
             </a:r>
           </a:p>
           <a:p/>
           <a:p>
             <a:r>
-              <a:t>And the dataset supplies no price series for Asclepius — a gap in the data, not a fact about the company. Volatility is most of what let the model size a bad outcome, so the bands are about 69 points wide. That width is correct, not something more modelling closes.</a:t>
+              <a:t>[CUT IF LONG] And severity ranking: 61 per cent of the announcements in the model's worst decile fell more than ten per cent. It sorts readouts into 'could be severe' and 'probably won't be', not into a number.</a:t>
             </a:r>
           </a:p>
         </p:txBody>
@@ -842,31 +849,31 @@
           <a:lstStyle/>
           <a:p>
             <a:r>
-              <a:t>[2:18 — ~52s]</a:t>
+              <a:t>[1:47 — ~52s]</a:t>
             </a:r>
           </a:p>
           <a:p/>
           <a:p>
             <a:r>
-              <a:t>I used Claude, through Claude Code, heavily and throughout — to write and debug the code, to pull result sentences out of the filings so I could read them, and to draft commentary I then rewrote. The full conversations are in the submitted log.</a:t>
+              <a:t>Now the limits, and they're real.</a:t>
             </a:r>
           </a:p>
           <a:p/>
           <a:p>
             <a:r>
-              <a:t>What I didn't delegate was the judgement. I set the constraints: no feature that wasn't observable before the event, and the illustrative announcement drafts excluded entirely, because they were written to express the assumed outcome. The thirty filings I read against the original 8-Ks are my reading, not its summary.</a:t>
+              <a:t>ASC-101 has effectively no comparables. The dataset holds seven hereditary angioedema readouts in total, so my method matched it to vaccine trials on design, having nothing to match on disease. That number is a Phase 3 base rate wearing a comparable set's clothes.</a:t>
             </a:r>
           </a:p>
           <a:p/>
           <a:p>
             <a:r>
-              <a:t>And I corrected it. It mapped all three mixed scenarios to mixed-positive; I read the ASC-204 draft, saw a missed primary endpoint rescued by a subgroup, and moved it to mixed-negative.</a:t>
+              <a:t>The upside is close to unmodelled — three per cent of the spread within positive readouts, and effectively nothing with the features Asclepius can supply. For an upside case, quote the historical range.</a:t>
             </a:r>
           </a:p>
           <a:p/>
           <a:p>
             <a:r>
-              <a:t>(If asked for more: it hard-coded a cluster by number, which breaks because k-means relabels on refit; and its first ablation conflated losing the text with losing the price history, so I had it split the comparison.)</a:t>
+              <a:t>And the dataset supplies no price series for Asclepius — a gap in the data, not a fact about the company. Volatility is most of what let the model size a bad outcome, so the bands are about 69 points wide, and correctly so.</a:t>
             </a:r>
           </a:p>
         </p:txBody>
@@ -936,31 +943,31 @@
           <a:lstStyle/>
           <a:p>
             <a:r>
-              <a:t>[3:10 — ~53s]</a:t>
+              <a:t>[2:39 — ~47s]</a:t>
             </a:r>
           </a:p>
           <a:p/>
           <a:p>
             <a:r>
-              <a:t>On checking, three things I'd point you at.</a:t>
+              <a:t>I used Claude, through Claude Code, heavily and throughout — to write and debug the code, to surface result sentences from the filings for me to read, and to draft commentary I rewrote. The full conversations are in the submitted log.</a:t>
             </a:r>
           </a:p>
           <a:p/>
           <a:p>
             <a:r>
-              <a:t>I ran a leakage audit before fitting anything. With the nine excluded columns put back, R-squared goes from 0.20 to 0.96. The one that mattered was my own data-quality index — it lifted R-squared by 0.14, until I traced it to one signal built from the realised return. That's the leakage that survives review — the name gives nothing away.</a:t>
+              <a:t>What I didn't delegate was the judgement. I set the constraints: no feature unobservable before the event, and the announcement drafts excluded entirely, because they were written to express the assumed outcome. The thirty filings are my reading, not its summary.</a:t>
             </a:r>
           </a:p>
           <a:p/>
           <a:p>
             <a:r>
-              <a:t>[CUT IF LONG] I validated against honest nulls — permuted features for the clustering, bootstrap by filing rather than by row, and forward chaining, which drops R-squared from 0.20 to 0.17. That's what the pipeline can deliver.</a:t>
+              <a:t>And I corrected it. It mapped all three mixed scenarios to mixed-positive; I read the ASC-204 draft, saw a missed primary endpoint rescued by a subgroup, and moved it to mixed-negative.</a:t>
             </a:r>
           </a:p>
           <a:p/>
           <a:p>
             <a:r>
-              <a:t>And I corrected my own claims: I'd told the team the range width was mainly the unknown result. It's about a quarter.</a:t>
+              <a:t>(If asked for more: it hard-coded a cluster by number, which breaks because k-means relabels on refit; and its first ablation conflated losing the text with losing the price history, so I had it split the comparison.)</a:t>
             </a:r>
           </a:p>
         </p:txBody>
@@ -1030,25 +1037,113 @@
           <a:lstStyle/>
           <a:p>
             <a:r>
-              <a:t>[4:03 — ~31s]</a:t>
+              <a:t>[3:26 — ~45s]</a:t>
             </a:r>
           </a:p>
           <a:p/>
           <a:p>
             <a:r>
-              <a:t>Under PG1 I'm responsible for the judgements here regardless of what produced the first draft of them — which means understanding the model before relying on it, and judging whether its assumptions suit the purpose. That's what I've tried to do.</a:t>
+              <a:t>On checking. I ran a leakage audit before fitting anything: with the nine excluded columns put back, R-squared goes from 0.20 to 0.96. The one that mattered was my own data-quality index — worth 0.14, until I traced it to one signal built from the realised return. That's the leakage that survives review; the name gives nothing away.</a:t>
             </a:r>
           </a:p>
           <a:p/>
           <a:p>
             <a:r>
+              <a:t>[CUT IF LONG] I validated against honest nulls — permuted features, bootstrap by filing rather than by row, and forward chaining, which drops R-squared to 0.17. That's what the pipeline can deliver.</a:t>
+            </a:r>
+          </a:p>
+          <a:p/>
+          <a:p>
+            <a:r>
+              <a:t>And I corrected my own claims: I'd told the team the range width was mainly the unknown result. It's about a quarter.</a:t>
+            </a:r>
+          </a:p>
+        </p:txBody>
+      </p:sp>
+      <p:sp>
+        <p:nvSpPr>
+          <p:cNvPr id="4" name="Slide Number Placeholder 3"/>
+          <p:cNvSpPr>
+            <a:spLocks noGrp="1"/>
+          </p:cNvSpPr>
+          <p:nvPr>
+            <p:ph type="sldNum" idx="5" sz="quarter"/>
+          </p:nvPr>
+        </p:nvSpPr>
+        <p:spPr/>
+      </p:sp>
+    </p:spTree>
+  </p:cSld>
+  <p:clrMapOvr>
+    <a:masterClrMapping/>
+  </p:clrMapOvr>
+</p:notes>
+</file>
+
+<file path=ppt/notesSlides/notesSlide8.xml><?xml version="1.0" encoding="utf-8"?>
+<p:notes xmlns:a="http://schemas.openxmlformats.org/drawingml/2006/main" xmlns:p="http://schemas.openxmlformats.org/presentationml/2006/main" xmlns:r="http://schemas.openxmlformats.org/officeDocument/2006/relationships">
+  <p:cSld>
+    <p:spTree>
+      <p:nvGrpSpPr>
+        <p:cNvPr id="1" name=""/>
+        <p:cNvGrpSpPr/>
+        <p:nvPr/>
+      </p:nvGrpSpPr>
+      <p:grpSpPr>
+        <a:xfrm>
+          <a:off x="0" y="0"/>
+          <a:ext cx="0" cy="0"/>
+          <a:chOff x="0" y="0"/>
+          <a:chExt cx="0" cy="0"/>
+        </a:xfrm>
+      </p:grpSpPr>
+      <p:sp>
+        <p:nvSpPr>
+          <p:cNvPr id="2" name="Slide Image Placeholder 1"/>
+          <p:cNvSpPr>
+            <a:spLocks noGrp="1"/>
+          </p:cNvSpPr>
+          <p:nvPr>
+            <p:ph type="sldImg" idx="2"/>
+          </p:nvPr>
+        </p:nvSpPr>
+        <p:spPr/>
+      </p:sp>
+      <p:sp>
+        <p:nvSpPr>
+          <p:cNvPr id="3" name="Notes Placeholder 2"/>
+          <p:cNvSpPr>
+            <a:spLocks noGrp="1"/>
+          </p:cNvSpPr>
+          <p:nvPr>
+            <p:ph type="body" idx="3" sz="quarter"/>
+          </p:nvPr>
+        </p:nvSpPr>
+        <p:spPr/>
+        <p:txBody>
+          <a:bodyPr/>
+          <a:lstStyle/>
+          <a:p>
+            <a:r>
+              <a:t>[4:11 — ~29s]</a:t>
+            </a:r>
+          </a:p>
+          <a:p/>
+          <a:p>
+            <a:r>
+              <a:t>Under PG1 I'm responsible for the judgements here regardless of what produced the first draft of them — which means understanding the model before relying on it, and judging whether its assumptions suit the purpose.</a:t>
+            </a:r>
+          </a:p>
+          <a:p/>
+          <a:p>
+            <a:r>
               <a:t>If your time is limited, I'd put it on two things: my decision to exclude the announcement drafts, and whether the ASC-101 estimate should go in front of the board at all. Thank you.</a:t>
             </a:r>
           </a:p>
           <a:p/>
           <a:p>
             <a:r>
-              <a:t>END — target 4:30, limit 5:00.</a:t>
+              <a:t>END — target 4:40, limit 5:00.</a:t>
             </a:r>
           </a:p>
         </p:txBody>
@@ -4458,7 +4553,7 @@
                 </a:solidFill>
                 <a:latin typeface="Calibri"/>
               </a:rPr>
-              <a:t>MY OPINION</a:t>
+              <a:t>WHAT I BUILT</a:t>
             </a:r>
           </a:p>
           <a:p>
@@ -4480,8 +4575,7 @@
                 </a:solidFill>
                 <a:latin typeface="Calibri"/>
               </a:rPr>
-              <a:t>Rely on it to inform —
-not to produce a number</a:t>
+              <a:t>Four stages</a:t>
             </a:r>
           </a:p>
         </p:txBody>
@@ -4494,7 +4588,7 @@
         </p:nvSpPr>
         <p:spPr>
           <a:xfrm>
-            <a:off x="5532120" y="2121408"/>
+            <a:off x="5532120" y="1847088"/>
             <a:ext cx="1371600" cy="38100"/>
           </a:xfrm>
           <a:prstGeom prst="rect">
@@ -4538,8 +4632,8 @@
         </p:nvSpPr>
         <p:spPr>
           <a:xfrm>
-            <a:off x="5532120" y="2395728"/>
-            <a:ext cx="6110935" cy="3657600"/>
+            <a:off x="5532120" y="2121408"/>
+            <a:ext cx="6110935" cy="4114800"/>
           </a:xfrm>
           <a:prstGeom prst="rect">
             <a:avLst/>
@@ -4560,111 +4654,23 @@
                 <a:spcPts val="0"/>
               </a:spcBef>
               <a:spcAft>
-                <a:spcPts val="400"/>
+                <a:spcPts val="300"/>
               </a:spcAft>
             </a:pPr>
             <a:r>
-              <a:rPr sz="2100" b="1" i="0">
+              <a:rPr sz="1800" b="1" i="0">
                 <a:solidFill>
                   <a:srgbClr val="141B2D"/>
                 </a:solidFill>
                 <a:latin typeface="Calibri"/>
               </a:rPr>
-              <a:t>Strong on the downside.</a:t>
+              <a:t>Validated the outcome labels.</a:t>
             </a:r>
           </a:p>
           <a:p>
             <a:pPr>
               <a:lnSpc>
-                <a:spcPct val="108000"/>
-              </a:lnSpc>
-              <a:spcBef>
-                <a:spcPts val="0"/>
-              </a:spcBef>
-              <a:spcAft>
-                <a:spcPts val="1600"/>
-              </a:spcAft>
-            </a:pPr>
-            <a:r>
-              <a:rPr sz="1500" b="0" i="0">
-                <a:solidFill>
-                  <a:srgbClr val="5A6478"/>
-                </a:solidFill>
-                <a:latin typeface="Calibri"/>
-              </a:rPr>
-              <a:t>R² = 0.31 within negative readouts</a:t>
-            </a:r>
-          </a:p>
-          <a:p>
-            <a:pPr>
-              <a:lnSpc>
-                <a:spcPct val="108000"/>
-              </a:lnSpc>
-              <a:spcBef>
-                <a:spcPts val="0"/>
-              </a:spcBef>
-              <a:spcAft>
-                <a:spcPts val="400"/>
-              </a:spcAft>
-            </a:pPr>
-            <a:r>
-              <a:rPr sz="2100" b="1" i="0">
-                <a:solidFill>
-                  <a:srgbClr val="A8322D"/>
-                </a:solidFill>
-                <a:latin typeface="Calibri"/>
-              </a:rPr>
-              <a:t>Weak on the upside.</a:t>
-            </a:r>
-          </a:p>
-          <a:p>
-            <a:pPr>
-              <a:lnSpc>
-                <a:spcPct val="108000"/>
-              </a:lnSpc>
-              <a:spcBef>
-                <a:spcPts val="0"/>
-              </a:spcBef>
-              <a:spcAft>
-                <a:spcPts val="1600"/>
-              </a:spcAft>
-            </a:pPr>
-            <a:r>
-              <a:rPr sz="1500" b="0" i="0">
-                <a:solidFill>
-                  <a:srgbClr val="5A6478"/>
-                </a:solidFill>
-                <a:latin typeface="Calibri"/>
-              </a:rPr>
-              <a:t>R² = 0.03 within positive readouts — use history, not the model</a:t>
-            </a:r>
-          </a:p>
-          <a:p>
-            <a:pPr>
-              <a:lnSpc>
-                <a:spcPct val="108000"/>
-              </a:lnSpc>
-              <a:spcBef>
-                <a:spcPts val="0"/>
-              </a:spcBef>
-              <a:spcAft>
-                <a:spcPts val="400"/>
-              </a:spcAft>
-            </a:pPr>
-            <a:r>
-              <a:rPr sz="2100" b="1" i="0">
-                <a:solidFill>
-                  <a:srgbClr val="141B2D"/>
-                </a:solidFill>
-                <a:latin typeface="Calibri"/>
-              </a:rPr>
-              <a:t>Not a forecast, a ranking.</a:t>
-            </a:r>
-          </a:p>
-          <a:p>
-            <a:pPr>
-              <a:lnSpc>
-                <a:spcPct val="108000"/>
+                <a:spcPct val="112000"/>
               </a:lnSpc>
               <a:spcBef>
                 <a:spcPts val="0"/>
@@ -4674,13 +4680,145 @@
               </a:spcAft>
             </a:pPr>
             <a:r>
-              <a:rPr sz="1500" b="0" i="0">
+              <a:rPr sz="1400" b="0" i="0">
                 <a:solidFill>
                   <a:srgbClr val="5A6478"/>
                 </a:solidFill>
                 <a:latin typeface="Calibri"/>
               </a:rPr>
-              <a:t>Typical error on a single event is about 21 percentage points</a:t>
+              <a:t>30 filings read by hand · all 2,392 directional labels checked against the realised move · a screen over all 4,539 classifications flags 40%, mostly timing rather than wrong labels.</a:t>
+            </a:r>
+          </a:p>
+          <a:p>
+            <a:pPr>
+              <a:lnSpc>
+                <a:spcPct val="108000"/>
+              </a:lnSpc>
+              <a:spcBef>
+                <a:spcPts val="1200"/>
+              </a:spcBef>
+              <a:spcAft>
+                <a:spcPts val="300"/>
+              </a:spcAft>
+            </a:pPr>
+            <a:r>
+              <a:rPr sz="1800" b="1" i="0">
+                <a:solidFill>
+                  <a:srgbClr val="141B2D"/>
+                </a:solidFill>
+                <a:latin typeface="Calibri"/>
+              </a:rPr>
+              <a:t>Grouped 1,975 readouts into eight families.</a:t>
+            </a:r>
+          </a:p>
+          <a:p>
+            <a:pPr>
+              <a:lnSpc>
+                <a:spcPct val="112000"/>
+              </a:lnSpc>
+              <a:spcBef>
+                <a:spcPts val="0"/>
+              </a:spcBef>
+              <a:spcAft>
+                <a:spcPts val="0"/>
+              </a:spcAft>
+            </a:pPr>
+            <a:r>
+              <a:rPr sz="1400" b="0" i="0">
+                <a:solidFill>
+                  <a:srgbClr val="5A6478"/>
+                </a:solidFill>
+                <a:latin typeface="Calibri"/>
+              </a:rPr>
+              <a:t>Disease, design, stage and sponsor — to find comparables for each readout.</a:t>
+            </a:r>
+          </a:p>
+          <a:p>
+            <a:pPr>
+              <a:lnSpc>
+                <a:spcPct val="108000"/>
+              </a:lnSpc>
+              <a:spcBef>
+                <a:spcPts val="1200"/>
+              </a:spcBef>
+              <a:spcAft>
+                <a:spcPts val="300"/>
+              </a:spcAft>
+            </a:pPr>
+            <a:r>
+              <a:rPr sz="1800" b="1" i="0">
+                <a:solidFill>
+                  <a:srgbClr val="141B2D"/>
+                </a:solidFill>
+                <a:latin typeface="Calibri"/>
+              </a:rPr>
+              <a:t>Modelled the three-day abnormal return.</a:t>
+            </a:r>
+          </a:p>
+          <a:p>
+            <a:pPr>
+              <a:lnSpc>
+                <a:spcPct val="112000"/>
+              </a:lnSpc>
+              <a:spcBef>
+                <a:spcPts val="0"/>
+              </a:spcBef>
+              <a:spcAft>
+                <a:spcPts val="0"/>
+              </a:spcAft>
+            </a:pPr>
+            <a:r>
+              <a:rPr sz="1400" b="0" i="0">
+                <a:solidFill>
+                  <a:srgbClr val="5A6478"/>
+                </a:solidFill>
+                <a:latin typeface="Calibri"/>
+              </a:rPr>
+              <a:t>Trial, text and company features, scored on held-out announcements. Explains 20%.</a:t>
+            </a:r>
+          </a:p>
+          <a:p>
+            <a:pPr>
+              <a:lnSpc>
+                <a:spcPct val="108000"/>
+              </a:lnSpc>
+              <a:spcBef>
+                <a:spcPts val="1200"/>
+              </a:spcBef>
+              <a:spcAft>
+                <a:spcPts val="300"/>
+              </a:spcAft>
+            </a:pPr>
+            <a:r>
+              <a:rPr sz="1800" b="1" i="0">
+                <a:solidFill>
+                  <a:srgbClr val="141B2D"/>
+                </a:solidFill>
+                <a:latin typeface="Calibri"/>
+              </a:rPr>
+              <a:t>Applied it to the three readouts.</a:t>
+            </a:r>
+          </a:p>
+          <a:p>
+            <a:pPr>
+              <a:lnSpc>
+                <a:spcPct val="112000"/>
+              </a:lnSpc>
+              <a:spcBef>
+                <a:spcPts val="0"/>
+              </a:spcBef>
+              <a:spcAft>
+                <a:spcPts val="0"/>
+              </a:spcAft>
+            </a:pPr>
+            <a:r>
+              <a:rPr sz="1400" b="0" i="0">
+                <a:solidFill>
+                  <a:srgbClr val="5A6478"/>
+                </a:solidFill>
+                <a:latin typeface="Calibri"/>
+              </a:rPr>
+              <a:t>Three scenarios each, plus a validation, monitoring and refresh plan.</a:t>
             </a:r>
           </a:p>
         </p:txBody>
@@ -4860,7 +4998,7 @@
                 </a:solidFill>
                 <a:latin typeface="Calibri"/>
               </a:rPr>
-              <a:t>WHAT THE ANALYSIS SUPPORTS</a:t>
+              <a:t>MY OPINION</a:t>
             </a:r>
           </a:p>
           <a:p>
@@ -4882,8 +5020,8 @@
                 </a:solidFill>
                 <a:latin typeface="Calibri"/>
               </a:rPr>
-              <a:t>Three things I'd
-stand behind</a:t>
+              <a:t>Rely on it to inform —
+not to produce a number</a:t>
             </a:r>
           </a:p>
         </p:txBody>
@@ -4896,7 +5034,7 @@
         </p:nvSpPr>
         <p:spPr>
           <a:xfrm>
-            <a:off x="5532120" y="1847088"/>
+            <a:off x="5532120" y="2121408"/>
             <a:ext cx="1371600" cy="38100"/>
           </a:xfrm>
           <a:prstGeom prst="rect">
@@ -4940,8 +5078,8 @@
         </p:nvSpPr>
         <p:spPr>
           <a:xfrm>
-            <a:off x="5532120" y="2121408"/>
-            <a:ext cx="6110935" cy="4114800"/>
+            <a:off x="5532120" y="2395728"/>
+            <a:ext cx="6110935" cy="3657600"/>
           </a:xfrm>
           <a:prstGeom prst="rect">
             <a:avLst/>
@@ -4962,23 +5100,111 @@
                 <a:spcPts val="0"/>
               </a:spcBef>
               <a:spcAft>
-                <a:spcPts val="300"/>
+                <a:spcPts val="400"/>
               </a:spcAft>
             </a:pPr>
             <a:r>
-              <a:rPr sz="1900" b="1" i="0">
+              <a:rPr sz="2100" b="1" i="0">
                 <a:solidFill>
                   <a:srgbClr val="141B2D"/>
                 </a:solidFill>
                 <a:latin typeface="Calibri"/>
               </a:rPr>
-              <a:t>The ordering is reliable.</a:t>
+              <a:t>Strong on the downside.</a:t>
             </a:r>
           </a:p>
           <a:p>
             <a:pPr>
               <a:lnSpc>
-                <a:spcPct val="112000"/>
+                <a:spcPct val="108000"/>
+              </a:lnSpc>
+              <a:spcBef>
+                <a:spcPts val="0"/>
+              </a:spcBef>
+              <a:spcAft>
+                <a:spcPts val="1600"/>
+              </a:spcAft>
+            </a:pPr>
+            <a:r>
+              <a:rPr sz="1500" b="0" i="0">
+                <a:solidFill>
+                  <a:srgbClr val="5A6478"/>
+                </a:solidFill>
+                <a:latin typeface="Calibri"/>
+              </a:rPr>
+              <a:t>R² = 0.31 within negative readouts</a:t>
+            </a:r>
+          </a:p>
+          <a:p>
+            <a:pPr>
+              <a:lnSpc>
+                <a:spcPct val="108000"/>
+              </a:lnSpc>
+              <a:spcBef>
+                <a:spcPts val="0"/>
+              </a:spcBef>
+              <a:spcAft>
+                <a:spcPts val="400"/>
+              </a:spcAft>
+            </a:pPr>
+            <a:r>
+              <a:rPr sz="2100" b="1" i="0">
+                <a:solidFill>
+                  <a:srgbClr val="A8322D"/>
+                </a:solidFill>
+                <a:latin typeface="Calibri"/>
+              </a:rPr>
+              <a:t>Weak on the upside.</a:t>
+            </a:r>
+          </a:p>
+          <a:p>
+            <a:pPr>
+              <a:lnSpc>
+                <a:spcPct val="108000"/>
+              </a:lnSpc>
+              <a:spcBef>
+                <a:spcPts val="0"/>
+              </a:spcBef>
+              <a:spcAft>
+                <a:spcPts val="1600"/>
+              </a:spcAft>
+            </a:pPr>
+            <a:r>
+              <a:rPr sz="1500" b="0" i="0">
+                <a:solidFill>
+                  <a:srgbClr val="5A6478"/>
+                </a:solidFill>
+                <a:latin typeface="Calibri"/>
+              </a:rPr>
+              <a:t>R² = 0.03 within positive readouts — use history, not the model</a:t>
+            </a:r>
+          </a:p>
+          <a:p>
+            <a:pPr>
+              <a:lnSpc>
+                <a:spcPct val="108000"/>
+              </a:lnSpc>
+              <a:spcBef>
+                <a:spcPts val="0"/>
+              </a:spcBef>
+              <a:spcAft>
+                <a:spcPts val="400"/>
+              </a:spcAft>
+            </a:pPr>
+            <a:r>
+              <a:rPr sz="2100" b="1" i="0">
+                <a:solidFill>
+                  <a:srgbClr val="141B2D"/>
+                </a:solidFill>
+                <a:latin typeface="Calibri"/>
+              </a:rPr>
+              <a:t>Not a forecast, a ranking.</a:t>
+            </a:r>
+          </a:p>
+          <a:p>
+            <a:pPr>
+              <a:lnSpc>
+                <a:spcPct val="108000"/>
               </a:lnSpc>
               <a:spcBef>
                 <a:spcPts val="0"/>
@@ -4994,95 +5220,7 @@
                 </a:solidFill>
                 <a:latin typeface="Calibri"/>
               </a:rPr>
-              <a:t>Negative vs positive separated by 16–27 points of central estimate, for all three assets, and it survives every seed.</a:t>
-            </a:r>
-          </a:p>
-          <a:p>
-            <a:pPr>
-              <a:lnSpc>
-                <a:spcPct val="108000"/>
-              </a:lnSpc>
-              <a:spcBef>
-                <a:spcPts val="1400"/>
-              </a:spcBef>
-              <a:spcAft>
-                <a:spcPts val="300"/>
-              </a:spcAft>
-            </a:pPr>
-            <a:r>
-              <a:rPr sz="1900" b="1" i="0">
-                <a:solidFill>
-                  <a:srgbClr val="141B2D"/>
-                </a:solidFill>
-                <a:latin typeface="Calibri"/>
-              </a:rPr>
-              <a:t>ASC-204's downside is well evidenced.</a:t>
-            </a:r>
-          </a:p>
-          <a:p>
-            <a:pPr>
-              <a:lnSpc>
-                <a:spcPct val="112000"/>
-              </a:lnSpc>
-              <a:spcBef>
-                <a:spcPts val="0"/>
-              </a:spcBef>
-              <a:spcAft>
-                <a:spcPts val="0"/>
-              </a:spcAft>
-            </a:pPr>
-            <a:r>
-              <a:rPr sz="1500" b="0" i="0">
-                <a:solidFill>
-                  <a:srgbClr val="5A6478"/>
-                </a:solidFill>
-                <a:latin typeface="Calibri"/>
-              </a:rPr>
-              <a:t>266-trial cardiovascular and renal cluster · 246 in the same therapeutic area · 34 negative readouts behind the distribution.</a:t>
-            </a:r>
-          </a:p>
-          <a:p>
-            <a:pPr>
-              <a:lnSpc>
-                <a:spcPct val="108000"/>
-              </a:lnSpc>
-              <a:spcBef>
-                <a:spcPts val="1400"/>
-              </a:spcBef>
-              <a:spcAft>
-                <a:spcPts val="300"/>
-              </a:spcAft>
-            </a:pPr>
-            <a:r>
-              <a:rPr sz="1900" b="1" i="0">
-                <a:solidFill>
-                  <a:srgbClr val="141B2D"/>
-                </a:solidFill>
-                <a:latin typeface="Calibri"/>
-              </a:rPr>
-              <a:t>It ranks severity.</a:t>
-            </a:r>
-          </a:p>
-          <a:p>
-            <a:pPr>
-              <a:lnSpc>
-                <a:spcPct val="112000"/>
-              </a:lnSpc>
-              <a:spcBef>
-                <a:spcPts val="0"/>
-              </a:spcBef>
-              <a:spcAft>
-                <a:spcPts val="0"/>
-              </a:spcAft>
-            </a:pPr>
-            <a:r>
-              <a:rPr sz="1500" b="0" i="0">
-                <a:solidFill>
-                  <a:srgbClr val="5A6478"/>
-                </a:solidFill>
-                <a:latin typeface="Calibri"/>
-              </a:rPr>
-              <a:t>Worst-ranked decile: 61% fell more than 10%, 43% more than 25%. AUC 0.78 for a fall beyond 25%.</a:t>
+              <a:t>Typical error on a single event is about 21 percentage points</a:t>
             </a:r>
           </a:p>
         </p:txBody>
@@ -5262,7 +5400,7 @@
                 </a:solidFill>
                 <a:latin typeface="Calibri"/>
               </a:rPr>
-              <a:t>WHERE IT SHOULD NOT BE RELIED UPON</a:t>
+              <a:t>WHAT THE ANALYSIS SUPPORTS</a:t>
             </a:r>
           </a:p>
           <a:p>
@@ -5280,12 +5418,12 @@
             <a:r>
               <a:rPr sz="3000" b="1" i="0">
                 <a:solidFill>
-                  <a:srgbClr val="A8322D"/>
+                  <a:srgbClr val="1F4E79"/>
                 </a:solidFill>
                 <a:latin typeface="Calibri"/>
               </a:rPr>
-              <a:t>Three limits,
-and they are real</a:t>
+              <a:t>Three things I'd
+stand behind</a:t>
             </a:r>
           </a:p>
         </p:txBody>
@@ -5305,7 +5443,7 @@
             <a:avLst/>
           </a:prstGeom>
           <a:solidFill>
-            <a:srgbClr val="A8322D"/>
+            <a:srgbClr val="1F4E79"/>
           </a:solidFill>
           <a:ln>
             <a:noFill/>
@@ -5374,7 +5512,7 @@
                 </a:solidFill>
                 <a:latin typeface="Calibri"/>
               </a:rPr>
-              <a:t>ASC-101 has effectively no comparables.</a:t>
+              <a:t>The ordering is reliable.</a:t>
             </a:r>
           </a:p>
           <a:p>
@@ -5396,7 +5534,7 @@
                 </a:solidFill>
                 <a:latin typeface="Calibri"/>
               </a:rPr>
-              <a:t>7 hereditary angioedema readouts in the whole dataset. Matched to vaccine trials on design because disease was unmatchable — a Phase 3 base rate, and it must be labelled as one.</a:t>
+              <a:t>Negative vs positive separated by 16–27 points of central estimate, for all three assets, and it survives every seed.</a:t>
             </a:r>
           </a:p>
           <a:p>
@@ -5418,7 +5556,7 @@
                 </a:solidFill>
                 <a:latin typeface="Calibri"/>
               </a:rPr>
-              <a:t>The upside is close to unmodelled.</a:t>
+              <a:t>ASC-204's downside is well evidenced.</a:t>
             </a:r>
           </a:p>
           <a:p>
@@ -5440,7 +5578,7 @@
                 </a:solidFill>
                 <a:latin typeface="Calibri"/>
               </a:rPr>
-              <a:t>R² ≈ 0.03 within positives, ~0 with the features Asclepius can supply. Quote the comparable-set range instead.</a:t>
+              <a:t>266-trial cardiovascular and renal cluster · 246 in the same therapeutic area · 34 negative readouts behind the distribution.</a:t>
             </a:r>
           </a:p>
           <a:p>
@@ -5462,7 +5600,7 @@
                 </a:solidFill>
                 <a:latin typeface="Calibri"/>
               </a:rPr>
-              <a:t>The dataset supplies no price series for ASCL.</a:t>
+              <a:t>It ranks severity.</a:t>
             </a:r>
           </a:p>
           <a:p>
@@ -5484,7 +5622,7 @@
                 </a:solidFill>
                 <a:latin typeface="Calibri"/>
               </a:rPr>
-              <a:t>A gap in the data, not a fact about the company. Volatility did most of the work in sizing a bad outcome, so bands are ~69 points wide — correctly wide.</a:t>
+              <a:t>Worst-ranked decile: 61% fell more than 10%, 43% more than 25%. AUC 0.78 for a fall beyond 25%.</a:t>
             </a:r>
           </a:p>
         </p:txBody>
@@ -5664,7 +5802,7 @@
                 </a:solidFill>
                 <a:latin typeface="Calibri"/>
               </a:rPr>
-              <a:t>HOW THE WORK WAS PRODUCED</a:t>
+              <a:t>WHERE IT SHOULD NOT BE RELIED UPON</a:t>
             </a:r>
           </a:p>
           <a:p>
@@ -5682,12 +5820,12 @@
             <a:r>
               <a:rPr sz="3000" b="1" i="0">
                 <a:solidFill>
-                  <a:srgbClr val="1F4E79"/>
+                  <a:srgbClr val="A8322D"/>
                 </a:solidFill>
                 <a:latin typeface="Calibri"/>
               </a:rPr>
-              <a:t>AI throughout —
-judgement not delegated</a:t>
+              <a:t>Three limits,
+and they are real</a:t>
             </a:r>
           </a:p>
         </p:txBody>
@@ -5707,7 +5845,7 @@
             <a:avLst/>
           </a:prstGeom>
           <a:solidFill>
-            <a:srgbClr val="1F4E79"/>
+            <a:srgbClr val="A8322D"/>
           </a:solidFill>
           <a:ln>
             <a:noFill/>
@@ -5776,7 +5914,7 @@
                 </a:solidFill>
                 <a:latin typeface="Calibri"/>
               </a:rPr>
-              <a:t>Claude, via Claude Code, heavily and throughout.</a:t>
+              <a:t>ASC-101 has effectively no comparables.</a:t>
             </a:r>
           </a:p>
           <a:p>
@@ -5798,7 +5936,7 @@
                 </a:solidFill>
                 <a:latin typeface="Calibri"/>
               </a:rPr>
-              <a:t>Code written and debugged, result sentences pulled from the filings for me to read, commentary drafted and then rewritten. Full logs submitted.</a:t>
+              <a:t>7 hereditary angioedema readouts in the whole dataset. Matched to vaccine trials on design because disease was unmatchable — a Phase 3 base rate, and it must be labelled as one.</a:t>
             </a:r>
           </a:p>
           <a:p>
@@ -5820,7 +5958,7 @@
                 </a:solidFill>
                 <a:latin typeface="Calibri"/>
               </a:rPr>
-              <a:t>The constraints were mine.</a:t>
+              <a:t>The upside is close to unmodelled.</a:t>
             </a:r>
           </a:p>
           <a:p>
@@ -5842,7 +5980,7 @@
                 </a:solidFill>
                 <a:latin typeface="Calibri"/>
               </a:rPr>
-              <a:t>No feature unobservable before the event. Announcement drafts excluded as circular. The 30 filings read against the 8-Ks are my reading.</a:t>
+              <a:t>R² ≈ 0.03 within positives, ~0 with the features Asclepius can supply. Quote the comparable-set range instead.</a:t>
             </a:r>
           </a:p>
           <a:p>
@@ -5864,7 +6002,7 @@
                 </a:solidFill>
                 <a:latin typeface="Calibri"/>
               </a:rPr>
-              <a:t>And I corrected it.</a:t>
+              <a:t>The dataset supplies no price series for ASCL.</a:t>
             </a:r>
           </a:p>
           <a:p>
@@ -5886,7 +6024,7 @@
                 </a:solidFill>
                 <a:latin typeface="Calibri"/>
               </a:rPr>
-              <a:t>It called all three mixed scenarios mixed-positive. ASC-204's misses its primary endpoint and is rescued by a subgroup — that is mixed-negative.</a:t>
+              <a:t>A gap in the data, not a fact about the company. Volatility did most of the work in sizing a bad outcome, so bands are ~69 points wide — correctly wide.</a:t>
             </a:r>
           </a:p>
         </p:txBody>
@@ -6066,7 +6204,7 @@
                 </a:solidFill>
                 <a:latin typeface="Calibri"/>
               </a:rPr>
-              <a:t>HOW I SATISFIED MYSELF IT IS SOUND</a:t>
+              <a:t>HOW THE WORK WAS PRODUCED</a:t>
             </a:r>
           </a:p>
           <a:p>
@@ -6088,8 +6226,8 @@
                 </a:solidFill>
                 <a:latin typeface="Calibri"/>
               </a:rPr>
-              <a:t>What I examined,
-and what it changed</a:t>
+              <a:t>AI throughout —
+judgement not delegated</a:t>
             </a:r>
           </a:p>
         </p:txBody>
@@ -6172,13 +6310,13 @@
               </a:spcAft>
             </a:pPr>
             <a:r>
-              <a:rPr sz="1800" b="1" i="0">
+              <a:rPr sz="1900" b="1" i="0">
                 <a:solidFill>
                   <a:srgbClr val="141B2D"/>
                 </a:solidFill>
                 <a:latin typeface="Calibri"/>
               </a:rPr>
-              <a:t>Leakage audit before anything was fitted.</a:t>
+              <a:t>Claude, via Claude Code, heavily and throughout.</a:t>
             </a:r>
           </a:p>
           <a:p>
@@ -6194,6 +6332,408 @@
               </a:spcAft>
             </a:pPr>
             <a:r>
+              <a:rPr sz="1500" b="0" i="0">
+                <a:solidFill>
+                  <a:srgbClr val="5A6478"/>
+                </a:solidFill>
+                <a:latin typeface="Calibri"/>
+              </a:rPr>
+              <a:t>Code written and debugged, result sentences pulled from the filings for me to read, commentary drafted and then rewritten. Full logs submitted.</a:t>
+            </a:r>
+          </a:p>
+          <a:p>
+            <a:pPr>
+              <a:lnSpc>
+                <a:spcPct val="108000"/>
+              </a:lnSpc>
+              <a:spcBef>
+                <a:spcPts val="1400"/>
+              </a:spcBef>
+              <a:spcAft>
+                <a:spcPts val="300"/>
+              </a:spcAft>
+            </a:pPr>
+            <a:r>
+              <a:rPr sz="1900" b="1" i="0">
+                <a:solidFill>
+                  <a:srgbClr val="141B2D"/>
+                </a:solidFill>
+                <a:latin typeface="Calibri"/>
+              </a:rPr>
+              <a:t>The constraints were mine.</a:t>
+            </a:r>
+          </a:p>
+          <a:p>
+            <a:pPr>
+              <a:lnSpc>
+                <a:spcPct val="112000"/>
+              </a:lnSpc>
+              <a:spcBef>
+                <a:spcPts val="0"/>
+              </a:spcBef>
+              <a:spcAft>
+                <a:spcPts val="0"/>
+              </a:spcAft>
+            </a:pPr>
+            <a:r>
+              <a:rPr sz="1500" b="0" i="0">
+                <a:solidFill>
+                  <a:srgbClr val="5A6478"/>
+                </a:solidFill>
+                <a:latin typeface="Calibri"/>
+              </a:rPr>
+              <a:t>No feature unobservable before the event. Announcement drafts excluded as circular. The 30 filings read against the 8-Ks are my reading.</a:t>
+            </a:r>
+          </a:p>
+          <a:p>
+            <a:pPr>
+              <a:lnSpc>
+                <a:spcPct val="108000"/>
+              </a:lnSpc>
+              <a:spcBef>
+                <a:spcPts val="1400"/>
+              </a:spcBef>
+              <a:spcAft>
+                <a:spcPts val="300"/>
+              </a:spcAft>
+            </a:pPr>
+            <a:r>
+              <a:rPr sz="1900" b="1" i="0">
+                <a:solidFill>
+                  <a:srgbClr val="141B2D"/>
+                </a:solidFill>
+                <a:latin typeface="Calibri"/>
+              </a:rPr>
+              <a:t>And I corrected it.</a:t>
+            </a:r>
+          </a:p>
+          <a:p>
+            <a:pPr>
+              <a:lnSpc>
+                <a:spcPct val="112000"/>
+              </a:lnSpc>
+              <a:spcBef>
+                <a:spcPts val="0"/>
+              </a:spcBef>
+              <a:spcAft>
+                <a:spcPts val="0"/>
+              </a:spcAft>
+            </a:pPr>
+            <a:r>
+              <a:rPr sz="1500" b="0" i="0">
+                <a:solidFill>
+                  <a:srgbClr val="5A6478"/>
+                </a:solidFill>
+                <a:latin typeface="Calibri"/>
+              </a:rPr>
+              <a:t>It called all three mixed scenarios mixed-positive. ASC-204's misses its primary endpoint and is rescued by a subgroup — that is mixed-negative.</a:t>
+            </a:r>
+          </a:p>
+        </p:txBody>
+      </p:sp>
+    </p:spTree>
+  </p:cSld>
+  <p:clrMapOvr>
+    <a:masterClrMapping/>
+  </p:clrMapOvr>
+</p:sld>
+</file>
+
+<file path=ppt/slides/slide7.xml><?xml version="1.0" encoding="utf-8"?>
+<p:sld xmlns:a="http://schemas.openxmlformats.org/drawingml/2006/main" xmlns:p="http://schemas.openxmlformats.org/presentationml/2006/main" xmlns:r="http://schemas.openxmlformats.org/officeDocument/2006/relationships">
+  <p:cSld>
+    <p:spTree>
+      <p:nvGrpSpPr>
+        <p:cNvPr id="1" name=""/>
+        <p:cNvGrpSpPr/>
+        <p:nvPr/>
+      </p:nvGrpSpPr>
+      <p:grpSpPr/>
+      <p:sp>
+        <p:nvSpPr>
+          <p:cNvPr id="2" name="Rectangle 1"/>
+          <p:cNvSpPr/>
+          <p:nvPr/>
+        </p:nvSpPr>
+        <p:spPr>
+          <a:xfrm>
+            <a:off x="0" y="0"/>
+            <a:ext cx="12191695" cy="6858000"/>
+          </a:xfrm>
+          <a:prstGeom prst="rect">
+            <a:avLst/>
+          </a:prstGeom>
+          <a:solidFill>
+            <a:srgbClr val="FFFFFF"/>
+          </a:solidFill>
+          <a:ln>
+            <a:noFill/>
+          </a:ln>
+          <a:effectLst/>
+        </p:spPr>
+        <p:style>
+          <a:lnRef idx="1">
+            <a:schemeClr val="accent1"/>
+          </a:lnRef>
+          <a:fillRef idx="3">
+            <a:schemeClr val="accent1"/>
+          </a:fillRef>
+          <a:effectRef idx="2">
+            <a:schemeClr val="accent1"/>
+          </a:effectRef>
+          <a:fontRef idx="minor">
+            <a:schemeClr val="lt1"/>
+          </a:fontRef>
+        </p:style>
+        <p:txBody>
+          <a:bodyPr rtlCol="0" anchor="ctr"/>
+          <a:lstStyle/>
+          <a:p>
+            <a:pPr algn="ctr"/>
+          </a:p>
+        </p:txBody>
+      </p:sp>
+      <p:sp>
+        <p:nvSpPr>
+          <p:cNvPr id="3" name="Rounded Rectangle 2"/>
+          <p:cNvSpPr/>
+          <p:nvPr/>
+        </p:nvSpPr>
+        <p:spPr>
+          <a:xfrm>
+            <a:off x="411480" y="685800"/>
+            <a:ext cx="4663440" cy="5486400"/>
+          </a:xfrm>
+          <a:prstGeom prst="roundRect">
+            <a:avLst>
+              <a:gd name="adj" fmla="val 2000"/>
+            </a:avLst>
+          </a:prstGeom>
+          <a:solidFill>
+            <a:srgbClr val="EDF0F5"/>
+          </a:solidFill>
+          <a:ln w="12700">
+            <a:solidFill>
+              <a:srgbClr val="C2CBD8"/>
+            </a:solidFill>
+          </a:ln>
+          <a:effectLst/>
+        </p:spPr>
+        <p:style>
+          <a:lnRef idx="1">
+            <a:schemeClr val="accent1"/>
+          </a:lnRef>
+          <a:fillRef idx="3">
+            <a:schemeClr val="accent1"/>
+          </a:fillRef>
+          <a:effectRef idx="2">
+            <a:schemeClr val="accent1"/>
+          </a:effectRef>
+          <a:fontRef idx="minor">
+            <a:schemeClr val="lt1"/>
+          </a:fontRef>
+        </p:style>
+        <p:txBody>
+          <a:bodyPr rtlCol="0" anchor="ctr" wrap="square"/>
+          <a:lstStyle/>
+          <a:p>
+            <a:pPr algn="ctr"/>
+            <a:r>
+              <a:rPr sz="1300" b="1">
+                <a:solidFill>
+                  <a:srgbClr val="9AA4B2"/>
+                </a:solidFill>
+                <a:latin typeface="Calibri"/>
+              </a:rPr>
+              <a:t>VIDEO</a:t>
+            </a:r>
+          </a:p>
+          <a:p>
+            <a:pPr algn="ctr">
+              <a:spcBef>
+                <a:spcPts val="400"/>
+              </a:spcBef>
+            </a:pPr>
+            <a:r>
+              <a:rPr sz="900">
+                <a:solidFill>
+                  <a:srgbClr val="9AA4B2"/>
+                </a:solidFill>
+                <a:latin typeface="Calibri"/>
+              </a:rPr>
+              <a:t>place your camera here · delete this shape before recording</a:t>
+            </a:r>
+          </a:p>
+        </p:txBody>
+      </p:sp>
+      <p:sp>
+        <p:nvSpPr>
+          <p:cNvPr id="4" name="TextBox 3"/>
+          <p:cNvSpPr txBox="1"/>
+          <p:nvPr/>
+        </p:nvSpPr>
+        <p:spPr>
+          <a:xfrm>
+            <a:off x="5532120" y="685800"/>
+            <a:ext cx="6110935" cy="1371600"/>
+          </a:xfrm>
+          <a:prstGeom prst="rect">
+            <a:avLst/>
+          </a:prstGeom>
+          <a:noFill/>
+        </p:spPr>
+        <p:txBody>
+          <a:bodyPr wrap="square">
+            <a:spAutoFit/>
+          </a:bodyPr>
+          <a:lstStyle/>
+          <a:p>
+            <a:pPr>
+              <a:lnSpc>
+                <a:spcPct val="108000"/>
+              </a:lnSpc>
+              <a:spcBef>
+                <a:spcPts val="0"/>
+              </a:spcBef>
+              <a:spcAft>
+                <a:spcPts val="600"/>
+              </a:spcAft>
+            </a:pPr>
+            <a:r>
+              <a:rPr sz="1200" b="1" i="0">
+                <a:solidFill>
+                  <a:srgbClr val="5A6478"/>
+                </a:solidFill>
+                <a:latin typeface="Calibri"/>
+              </a:rPr>
+              <a:t>HOW I SATISFIED MYSELF IT IS SOUND</a:t>
+            </a:r>
+          </a:p>
+          <a:p>
+            <a:pPr>
+              <a:lnSpc>
+                <a:spcPct val="100000"/>
+              </a:lnSpc>
+              <a:spcBef>
+                <a:spcPts val="0"/>
+              </a:spcBef>
+              <a:spcAft>
+                <a:spcPts val="0"/>
+              </a:spcAft>
+            </a:pPr>
+            <a:r>
+              <a:rPr sz="3000" b="1" i="0">
+                <a:solidFill>
+                  <a:srgbClr val="1F4E79"/>
+                </a:solidFill>
+                <a:latin typeface="Calibri"/>
+              </a:rPr>
+              <a:t>What I examined,
+and what it changed</a:t>
+            </a:r>
+          </a:p>
+        </p:txBody>
+      </p:sp>
+      <p:sp>
+        <p:nvSpPr>
+          <p:cNvPr id="5" name="Rectangle 4"/>
+          <p:cNvSpPr/>
+          <p:nvPr/>
+        </p:nvSpPr>
+        <p:spPr>
+          <a:xfrm>
+            <a:off x="5532120" y="1847088"/>
+            <a:ext cx="1371600" cy="38100"/>
+          </a:xfrm>
+          <a:prstGeom prst="rect">
+            <a:avLst/>
+          </a:prstGeom>
+          <a:solidFill>
+            <a:srgbClr val="1F4E79"/>
+          </a:solidFill>
+          <a:ln>
+            <a:noFill/>
+          </a:ln>
+          <a:effectLst/>
+        </p:spPr>
+        <p:style>
+          <a:lnRef idx="1">
+            <a:schemeClr val="accent1"/>
+          </a:lnRef>
+          <a:fillRef idx="3">
+            <a:schemeClr val="accent1"/>
+          </a:fillRef>
+          <a:effectRef idx="2">
+            <a:schemeClr val="accent1"/>
+          </a:effectRef>
+          <a:fontRef idx="minor">
+            <a:schemeClr val="lt1"/>
+          </a:fontRef>
+        </p:style>
+        <p:txBody>
+          <a:bodyPr rtlCol="0" anchor="ctr"/>
+          <a:lstStyle/>
+          <a:p>
+            <a:pPr algn="ctr"/>
+          </a:p>
+        </p:txBody>
+      </p:sp>
+      <p:sp>
+        <p:nvSpPr>
+          <p:cNvPr id="6" name="TextBox 5"/>
+          <p:cNvSpPr txBox="1"/>
+          <p:nvPr/>
+        </p:nvSpPr>
+        <p:spPr>
+          <a:xfrm>
+            <a:off x="5532120" y="2121408"/>
+            <a:ext cx="6110935" cy="4114800"/>
+          </a:xfrm>
+          <a:prstGeom prst="rect">
+            <a:avLst/>
+          </a:prstGeom>
+          <a:noFill/>
+        </p:spPr>
+        <p:txBody>
+          <a:bodyPr wrap="square">
+            <a:spAutoFit/>
+          </a:bodyPr>
+          <a:lstStyle/>
+          <a:p>
+            <a:pPr>
+              <a:lnSpc>
+                <a:spcPct val="108000"/>
+              </a:lnSpc>
+              <a:spcBef>
+                <a:spcPts val="0"/>
+              </a:spcBef>
+              <a:spcAft>
+                <a:spcPts val="300"/>
+              </a:spcAft>
+            </a:pPr>
+            <a:r>
+              <a:rPr sz="1800" b="1" i="0">
+                <a:solidFill>
+                  <a:srgbClr val="141B2D"/>
+                </a:solidFill>
+                <a:latin typeface="Calibri"/>
+              </a:rPr>
+              <a:t>Leakage audit before anything was fitted.</a:t>
+            </a:r>
+          </a:p>
+          <a:p>
+            <a:pPr>
+              <a:lnSpc>
+                <a:spcPct val="112000"/>
+              </a:lnSpc>
+              <a:spcBef>
+                <a:spcPts val="0"/>
+              </a:spcBef>
+              <a:spcAft>
+                <a:spcPts val="0"/>
+              </a:spcAft>
+            </a:pPr>
+            <a:r>
               <a:rPr sz="1400" b="0" i="0">
                 <a:solidFill>
                   <a:srgbClr val="5A6478"/>
@@ -6345,7 +6885,7 @@
 </p:sld>
 </file>
 
-<file path=ppt/slides/slide7.xml><?xml version="1.0" encoding="utf-8"?>
+<file path=ppt/slides/slide8.xml><?xml version="1.0" encoding="utf-8"?>
 <p:sld xmlns:a="http://schemas.openxmlformats.org/drawingml/2006/main" xmlns:p="http://schemas.openxmlformats.org/presentationml/2006/main" xmlns:r="http://schemas.openxmlformats.org/officeDocument/2006/relationships">
   <p:cSld>
     <p:spTree>

</xml_diff>